<commit_message>
feat: single-line slide titles, overlap detection, and speed optimization docs
- Rewrite draw_slide_title to always single-line via auto-shrink font (34pt -> min 18pt)
- Add detect_overlaps() and check_and_report_overlaps() to design.py
- Integrate overlap check into renderer (excludes footer region)
- Fix content.py: reserve space for source notes to prevent bullet overlap
- Fix data_highlight.py: narrower number width, dynamic notes positioning
- Fix quote.py: narrower quote mark, prevent overlay with quote text
- Update README with latest demo metrics and known issues
</commit_message>
<xml_diff>
--- a/assets/template.pptx
+++ b/assets/template.pptx
@@ -3552,7 +3552,7 @@
         <p:spPr>
           <a:xfrm>
             <a:off x="914400" y="1280160"/>
-            <a:ext cx="1371600" cy="914400"/>
+            <a:ext cx="731520" cy="914400"/>
           </a:xfrm>
           <a:prstGeom prst="rect">
             <a:avLst/>
@@ -3586,7 +3586,7 @@
         </p:nvSpPr>
         <p:spPr>
           <a:xfrm>
-            <a:off x="1828800" y="1737360"/>
+            <a:off x="1645920" y="1737360"/>
             <a:ext cx="9144000" cy="1466849"/>
           </a:xfrm>
           <a:prstGeom prst="rect">
@@ -4370,7 +4370,7 @@
         <p:spPr>
           <a:xfrm>
             <a:off x="914400" y="1005840"/>
-            <a:ext cx="10362895" cy="914400"/>
+            <a:ext cx="10362895" cy="822960"/>
           </a:xfrm>
           <a:prstGeom prst="rect">
             <a:avLst/>
@@ -4404,8 +4404,8 @@
         </p:nvSpPr>
         <p:spPr>
           <a:xfrm>
-            <a:off x="914400" y="2286000"/>
-            <a:ext cx="10362895" cy="3337560"/>
+            <a:off x="914400" y="2057400"/>
+            <a:ext cx="10362895" cy="3246120"/>
           </a:xfrm>
           <a:prstGeom prst="rect">
             <a:avLst/>
@@ -4491,7 +4491,7 @@
         </p:nvSpPr>
         <p:spPr>
           <a:xfrm>
-            <a:off x="914400" y="5394960"/>
+            <a:off x="914400" y="5349240"/>
             <a:ext cx="10362895" cy="228600"/>
           </a:xfrm>
           <a:prstGeom prst="rect">
@@ -4701,7 +4701,7 @@
         <p:spPr>
           <a:xfrm>
             <a:off x="914400" y="1005840"/>
-            <a:ext cx="10362895" cy="914400"/>
+            <a:ext cx="10362895" cy="822960"/>
           </a:xfrm>
           <a:prstGeom prst="rect">
             <a:avLst/>
@@ -4735,8 +4735,8 @@
         </p:nvSpPr>
         <p:spPr>
           <a:xfrm>
-            <a:off x="914400" y="2286000"/>
-            <a:ext cx="4846320" cy="3337560"/>
+            <a:off x="914400" y="2057400"/>
+            <a:ext cx="4846320" cy="3566160"/>
           </a:xfrm>
           <a:prstGeom prst="roundRect">
             <a:avLst/>
@@ -4778,8 +4778,8 @@
         </p:nvSpPr>
         <p:spPr>
           <a:xfrm>
-            <a:off x="1188720" y="2468880"/>
-            <a:ext cx="4297680" cy="2971800"/>
+            <a:off x="1188720" y="2240280"/>
+            <a:ext cx="4297680" cy="3200400"/>
           </a:xfrm>
           <a:prstGeom prst="rect">
             <a:avLst/>
@@ -4865,8 +4865,8 @@
         </p:nvSpPr>
         <p:spPr>
           <a:xfrm>
-            <a:off x="6035040" y="2286000"/>
-            <a:ext cx="4846320" cy="3337560"/>
+            <a:off x="6035040" y="2057400"/>
+            <a:ext cx="4846320" cy="3566160"/>
           </a:xfrm>
           <a:prstGeom prst="roundRect">
             <a:avLst/>
@@ -4908,8 +4908,8 @@
         </p:nvSpPr>
         <p:spPr>
           <a:xfrm>
-            <a:off x="6309360" y="2468880"/>
-            <a:ext cx="4297680" cy="2971800"/>
+            <a:off x="6309360" y="2240280"/>
+            <a:ext cx="4297680" cy="3200400"/>
           </a:xfrm>
           <a:prstGeom prst="rect">
             <a:avLst/>
@@ -5135,7 +5135,7 @@
         <p:spPr>
           <a:xfrm>
             <a:off x="914400" y="1005840"/>
-            <a:ext cx="10362895" cy="914400"/>
+            <a:ext cx="10362895" cy="822960"/>
           </a:xfrm>
           <a:prstGeom prst="rect">
             <a:avLst/>
@@ -5169,8 +5169,8 @@
         </p:nvSpPr>
         <p:spPr>
           <a:xfrm>
-            <a:off x="914400" y="2286000"/>
-            <a:ext cx="3200400" cy="3337560"/>
+            <a:off x="914400" y="2057400"/>
+            <a:ext cx="3200400" cy="3566160"/>
           </a:xfrm>
           <a:prstGeom prst="roundRect">
             <a:avLst/>
@@ -5212,7 +5212,7 @@
         </p:nvSpPr>
         <p:spPr>
           <a:xfrm>
-            <a:off x="914400" y="2286000"/>
+            <a:off x="914400" y="2057400"/>
             <a:ext cx="3200400" cy="50800"/>
           </a:xfrm>
           <a:prstGeom prst="rect">
@@ -5255,7 +5255,7 @@
         </p:nvSpPr>
         <p:spPr>
           <a:xfrm>
-            <a:off x="1143000" y="2560320"/>
+            <a:off x="1143000" y="2331720"/>
             <a:ext cx="2743200" cy="548640"/>
           </a:xfrm>
           <a:prstGeom prst="rect">
@@ -5290,8 +5290,8 @@
         </p:nvSpPr>
         <p:spPr>
           <a:xfrm>
-            <a:off x="1143000" y="3291840"/>
-            <a:ext cx="2743200" cy="1965960"/>
+            <a:off x="1143000" y="3063240"/>
+            <a:ext cx="2743200" cy="2194560"/>
           </a:xfrm>
           <a:prstGeom prst="rect">
             <a:avLst/>
@@ -5329,8 +5329,8 @@
         </p:nvSpPr>
         <p:spPr>
           <a:xfrm>
-            <a:off x="4434840" y="2286000"/>
-            <a:ext cx="3200400" cy="3337560"/>
+            <a:off x="4434840" y="2057400"/>
+            <a:ext cx="3200400" cy="3566160"/>
           </a:xfrm>
           <a:prstGeom prst="roundRect">
             <a:avLst/>
@@ -5372,7 +5372,7 @@
         </p:nvSpPr>
         <p:spPr>
           <a:xfrm>
-            <a:off x="4434840" y="2286000"/>
+            <a:off x="4434840" y="2057400"/>
             <a:ext cx="3200400" cy="50800"/>
           </a:xfrm>
           <a:prstGeom prst="rect">
@@ -5415,7 +5415,7 @@
         </p:nvSpPr>
         <p:spPr>
           <a:xfrm>
-            <a:off x="4663440" y="2560320"/>
+            <a:off x="4663440" y="2331720"/>
             <a:ext cx="2743200" cy="548640"/>
           </a:xfrm>
           <a:prstGeom prst="rect">
@@ -5450,8 +5450,8 @@
         </p:nvSpPr>
         <p:spPr>
           <a:xfrm>
-            <a:off x="4663440" y="3291840"/>
-            <a:ext cx="2743200" cy="1965960"/>
+            <a:off x="4663440" y="3063240"/>
+            <a:ext cx="2743200" cy="2194560"/>
           </a:xfrm>
           <a:prstGeom prst="rect">
             <a:avLst/>
@@ -5489,8 +5489,8 @@
         </p:nvSpPr>
         <p:spPr>
           <a:xfrm>
-            <a:off x="7955280" y="2286000"/>
-            <a:ext cx="3200400" cy="3337560"/>
+            <a:off x="7955280" y="2057400"/>
+            <a:ext cx="3200400" cy="3566160"/>
           </a:xfrm>
           <a:prstGeom prst="roundRect">
             <a:avLst/>
@@ -5532,7 +5532,7 @@
         </p:nvSpPr>
         <p:spPr>
           <a:xfrm>
-            <a:off x="7955280" y="2286000"/>
+            <a:off x="7955280" y="2057400"/>
             <a:ext cx="3200400" cy="50800"/>
           </a:xfrm>
           <a:prstGeom prst="rect">
@@ -5575,7 +5575,7 @@
         </p:nvSpPr>
         <p:spPr>
           <a:xfrm>
-            <a:off x="8183880" y="2560320"/>
+            <a:off x="8183880" y="2331720"/>
             <a:ext cx="2743200" cy="548640"/>
           </a:xfrm>
           <a:prstGeom prst="rect">
@@ -5610,8 +5610,8 @@
         </p:nvSpPr>
         <p:spPr>
           <a:xfrm>
-            <a:off x="8183880" y="3291840"/>
-            <a:ext cx="2743200" cy="1965960"/>
+            <a:off x="8183880" y="3063240"/>
+            <a:ext cx="2743200" cy="2194560"/>
           </a:xfrm>
           <a:prstGeom prst="rect">
             <a:avLst/>
@@ -6076,7 +6076,7 @@
         <p:spPr>
           <a:xfrm>
             <a:off x="914400" y="1005840"/>
-            <a:ext cx="10362895" cy="914400"/>
+            <a:ext cx="10362895" cy="822960"/>
           </a:xfrm>
           <a:prstGeom prst="rect">
             <a:avLst/>
@@ -6110,7 +6110,7 @@
         </p:nvSpPr>
         <p:spPr>
           <a:xfrm>
-            <a:off x="1371600" y="3954780"/>
+            <a:off x="1371600" y="3840480"/>
             <a:ext cx="9448495" cy="38100"/>
           </a:xfrm>
           <a:prstGeom prst="rect">
@@ -6153,7 +6153,7 @@
         </p:nvSpPr>
         <p:spPr>
           <a:xfrm>
-            <a:off x="1280160" y="3863340"/>
+            <a:off x="1280160" y="3749040"/>
             <a:ext cx="182880" cy="182880"/>
           </a:xfrm>
           <a:prstGeom prst="ellipse">
@@ -6196,7 +6196,7 @@
         </p:nvSpPr>
         <p:spPr>
           <a:xfrm>
-            <a:off x="640080" y="3451860"/>
+            <a:off x="640080" y="3337560"/>
             <a:ext cx="1463040" cy="365760"/>
           </a:xfrm>
           <a:prstGeom prst="rect">
@@ -6231,7 +6231,7 @@
         </p:nvSpPr>
         <p:spPr>
           <a:xfrm>
-            <a:off x="640080" y="4091940"/>
+            <a:off x="640080" y="3977640"/>
             <a:ext cx="1463040" cy="1371600"/>
           </a:xfrm>
           <a:prstGeom prst="rect">
@@ -6267,7 +6267,7 @@
         </p:nvSpPr>
         <p:spPr>
           <a:xfrm>
-            <a:off x="3642283" y="3863340"/>
+            <a:off x="3642283" y="3749040"/>
             <a:ext cx="182880" cy="182880"/>
           </a:xfrm>
           <a:prstGeom prst="ellipse">
@@ -6310,7 +6310,7 @@
         </p:nvSpPr>
         <p:spPr>
           <a:xfrm>
-            <a:off x="3002203" y="3451860"/>
+            <a:off x="3002203" y="3337560"/>
             <a:ext cx="1463040" cy="365760"/>
           </a:xfrm>
           <a:prstGeom prst="rect">
@@ -6345,7 +6345,7 @@
         </p:nvSpPr>
         <p:spPr>
           <a:xfrm>
-            <a:off x="3002203" y="4091940"/>
+            <a:off x="3002203" y="3977640"/>
             <a:ext cx="1463040" cy="1371600"/>
           </a:xfrm>
           <a:prstGeom prst="rect">
@@ -6381,7 +6381,7 @@
         </p:nvSpPr>
         <p:spPr>
           <a:xfrm>
-            <a:off x="6004407" y="3863340"/>
+            <a:off x="6004407" y="3749040"/>
             <a:ext cx="182880" cy="182880"/>
           </a:xfrm>
           <a:prstGeom prst="ellipse">
@@ -6424,7 +6424,7 @@
         </p:nvSpPr>
         <p:spPr>
           <a:xfrm>
-            <a:off x="5364327" y="3451860"/>
+            <a:off x="5364327" y="3337560"/>
             <a:ext cx="1463040" cy="365760"/>
           </a:xfrm>
           <a:prstGeom prst="rect">
@@ -6459,7 +6459,7 @@
         </p:nvSpPr>
         <p:spPr>
           <a:xfrm>
-            <a:off x="5364327" y="4091940"/>
+            <a:off x="5364327" y="3977640"/>
             <a:ext cx="1463040" cy="1371600"/>
           </a:xfrm>
           <a:prstGeom prst="rect">
@@ -6495,7 +6495,7 @@
         </p:nvSpPr>
         <p:spPr>
           <a:xfrm>
-            <a:off x="8366531" y="3863340"/>
+            <a:off x="8366531" y="3749040"/>
             <a:ext cx="182880" cy="182880"/>
           </a:xfrm>
           <a:prstGeom prst="ellipse">
@@ -6538,7 +6538,7 @@
         </p:nvSpPr>
         <p:spPr>
           <a:xfrm>
-            <a:off x="7726451" y="3451860"/>
+            <a:off x="7726451" y="3337560"/>
             <a:ext cx="1463040" cy="365760"/>
           </a:xfrm>
           <a:prstGeom prst="rect">
@@ -6573,7 +6573,7 @@
         </p:nvSpPr>
         <p:spPr>
           <a:xfrm>
-            <a:off x="7726451" y="4091940"/>
+            <a:off x="7726451" y="3977640"/>
             <a:ext cx="1463040" cy="1371600"/>
           </a:xfrm>
           <a:prstGeom prst="rect">
@@ -6609,7 +6609,7 @@
         </p:nvSpPr>
         <p:spPr>
           <a:xfrm>
-            <a:off x="10728655" y="3863340"/>
+            <a:off x="10728655" y="3749040"/>
             <a:ext cx="182880" cy="182880"/>
           </a:xfrm>
           <a:prstGeom prst="ellipse">
@@ -6652,7 +6652,7 @@
         </p:nvSpPr>
         <p:spPr>
           <a:xfrm>
-            <a:off x="10088575" y="3451860"/>
+            <a:off x="10088575" y="3337560"/>
             <a:ext cx="1463040" cy="365760"/>
           </a:xfrm>
           <a:prstGeom prst="rect">
@@ -6687,7 +6687,7 @@
         </p:nvSpPr>
         <p:spPr>
           <a:xfrm>
-            <a:off x="10088575" y="4091940"/>
+            <a:off x="10088575" y="3977640"/>
             <a:ext cx="1463040" cy="1371600"/>
           </a:xfrm>
           <a:prstGeom prst="rect">
@@ -6898,7 +6898,7 @@
         <p:spPr>
           <a:xfrm>
             <a:off x="914400" y="1005840"/>
-            <a:ext cx="10362895" cy="914400"/>
+            <a:ext cx="10362895" cy="822960"/>
           </a:xfrm>
           <a:prstGeom prst="rect">
             <a:avLst/>
@@ -6932,8 +6932,8 @@
         </p:nvSpPr>
         <p:spPr>
           <a:xfrm>
-            <a:off x="914400" y="2286000"/>
-            <a:ext cx="2590723" cy="556260"/>
+            <a:off x="914400" y="2057400"/>
+            <a:ext cx="2590723" cy="594360"/>
           </a:xfrm>
           <a:prstGeom prst="rect">
             <a:avLst/>
@@ -6977,8 +6977,8 @@
         </p:nvSpPr>
         <p:spPr>
           <a:xfrm>
-            <a:off x="1005840" y="2331720"/>
-            <a:ext cx="2407843" cy="464820"/>
+            <a:off x="1005840" y="2103120"/>
+            <a:ext cx="2407843" cy="502920"/>
           </a:xfrm>
           <a:prstGeom prst="rect">
             <a:avLst/>
@@ -7013,8 +7013,8 @@
         </p:nvSpPr>
         <p:spPr>
           <a:xfrm>
-            <a:off x="3505123" y="2286000"/>
-            <a:ext cx="2590723" cy="556260"/>
+            <a:off x="3505123" y="2057400"/>
+            <a:ext cx="2590723" cy="594360"/>
           </a:xfrm>
           <a:prstGeom prst="rect">
             <a:avLst/>
@@ -7058,8 +7058,8 @@
         </p:nvSpPr>
         <p:spPr>
           <a:xfrm>
-            <a:off x="3596563" y="2331720"/>
-            <a:ext cx="2407843" cy="464820"/>
+            <a:off x="3596563" y="2103120"/>
+            <a:ext cx="2407843" cy="502920"/>
           </a:xfrm>
           <a:prstGeom prst="rect">
             <a:avLst/>
@@ -7094,8 +7094,8 @@
         </p:nvSpPr>
         <p:spPr>
           <a:xfrm>
-            <a:off x="6095847" y="2286000"/>
-            <a:ext cx="2590723" cy="556260"/>
+            <a:off x="6095847" y="2057400"/>
+            <a:ext cx="2590723" cy="594360"/>
           </a:xfrm>
           <a:prstGeom prst="rect">
             <a:avLst/>
@@ -7139,8 +7139,8 @@
         </p:nvSpPr>
         <p:spPr>
           <a:xfrm>
-            <a:off x="6187287" y="2331720"/>
-            <a:ext cx="2407843" cy="464820"/>
+            <a:off x="6187287" y="2103120"/>
+            <a:ext cx="2407843" cy="502920"/>
           </a:xfrm>
           <a:prstGeom prst="rect">
             <a:avLst/>
@@ -7175,8 +7175,8 @@
         </p:nvSpPr>
         <p:spPr>
           <a:xfrm>
-            <a:off x="8686571" y="2286000"/>
-            <a:ext cx="2590723" cy="556260"/>
+            <a:off x="8686571" y="2057400"/>
+            <a:ext cx="2590723" cy="594360"/>
           </a:xfrm>
           <a:prstGeom prst="rect">
             <a:avLst/>
@@ -7220,8 +7220,8 @@
         </p:nvSpPr>
         <p:spPr>
           <a:xfrm>
-            <a:off x="8778011" y="2331720"/>
-            <a:ext cx="2407843" cy="464820"/>
+            <a:off x="8778011" y="2103120"/>
+            <a:ext cx="2407843" cy="502920"/>
           </a:xfrm>
           <a:prstGeom prst="rect">
             <a:avLst/>
@@ -7256,8 +7256,8 @@
         </p:nvSpPr>
         <p:spPr>
           <a:xfrm>
-            <a:off x="914400" y="2842260"/>
-            <a:ext cx="2590723" cy="556260"/>
+            <a:off x="914400" y="2651760"/>
+            <a:ext cx="2590723" cy="594360"/>
           </a:xfrm>
           <a:prstGeom prst="rect">
             <a:avLst/>
@@ -7301,8 +7301,8 @@
         </p:nvSpPr>
         <p:spPr>
           <a:xfrm>
-            <a:off x="1005840" y="2887980"/>
-            <a:ext cx="2407843" cy="464820"/>
+            <a:off x="1005840" y="2697480"/>
+            <a:ext cx="2407843" cy="502920"/>
           </a:xfrm>
           <a:prstGeom prst="rect">
             <a:avLst/>
@@ -7337,8 +7337,8 @@
         </p:nvSpPr>
         <p:spPr>
           <a:xfrm>
-            <a:off x="3505123" y="2842260"/>
-            <a:ext cx="2590723" cy="556260"/>
+            <a:off x="3505123" y="2651760"/>
+            <a:ext cx="2590723" cy="594360"/>
           </a:xfrm>
           <a:prstGeom prst="rect">
             <a:avLst/>
@@ -7382,8 +7382,8 @@
         </p:nvSpPr>
         <p:spPr>
           <a:xfrm>
-            <a:off x="3596563" y="2887980"/>
-            <a:ext cx="2407843" cy="464820"/>
+            <a:off x="3596563" y="2697480"/>
+            <a:ext cx="2407843" cy="502920"/>
           </a:xfrm>
           <a:prstGeom prst="rect">
             <a:avLst/>
@@ -7418,8 +7418,8 @@
         </p:nvSpPr>
         <p:spPr>
           <a:xfrm>
-            <a:off x="6095847" y="2842260"/>
-            <a:ext cx="2590723" cy="556260"/>
+            <a:off x="6095847" y="2651760"/>
+            <a:ext cx="2590723" cy="594360"/>
           </a:xfrm>
           <a:prstGeom prst="rect">
             <a:avLst/>
@@ -7463,8 +7463,8 @@
         </p:nvSpPr>
         <p:spPr>
           <a:xfrm>
-            <a:off x="6187287" y="2887980"/>
-            <a:ext cx="2407843" cy="464820"/>
+            <a:off x="6187287" y="2697480"/>
+            <a:ext cx="2407843" cy="502920"/>
           </a:xfrm>
           <a:prstGeom prst="rect">
             <a:avLst/>
@@ -7499,8 +7499,8 @@
         </p:nvSpPr>
         <p:spPr>
           <a:xfrm>
-            <a:off x="8686571" y="2842260"/>
-            <a:ext cx="2590723" cy="556260"/>
+            <a:off x="8686571" y="2651760"/>
+            <a:ext cx="2590723" cy="594360"/>
           </a:xfrm>
           <a:prstGeom prst="rect">
             <a:avLst/>
@@ -7544,8 +7544,8 @@
         </p:nvSpPr>
         <p:spPr>
           <a:xfrm>
-            <a:off x="8778011" y="2887980"/>
-            <a:ext cx="2407843" cy="464820"/>
+            <a:off x="8778011" y="2697480"/>
+            <a:ext cx="2407843" cy="502920"/>
           </a:xfrm>
           <a:prstGeom prst="rect">
             <a:avLst/>
@@ -7580,8 +7580,8 @@
         </p:nvSpPr>
         <p:spPr>
           <a:xfrm>
-            <a:off x="914400" y="3398520"/>
-            <a:ext cx="2590723" cy="556260"/>
+            <a:off x="914400" y="3246120"/>
+            <a:ext cx="2590723" cy="594360"/>
           </a:xfrm>
           <a:prstGeom prst="rect">
             <a:avLst/>
@@ -7625,8 +7625,8 @@
         </p:nvSpPr>
         <p:spPr>
           <a:xfrm>
-            <a:off x="1005840" y="3444240"/>
-            <a:ext cx="2407843" cy="464820"/>
+            <a:off x="1005840" y="3291840"/>
+            <a:ext cx="2407843" cy="502920"/>
           </a:xfrm>
           <a:prstGeom prst="rect">
             <a:avLst/>
@@ -7661,8 +7661,8 @@
         </p:nvSpPr>
         <p:spPr>
           <a:xfrm>
-            <a:off x="3505123" y="3398520"/>
-            <a:ext cx="2590723" cy="556260"/>
+            <a:off x="3505123" y="3246120"/>
+            <a:ext cx="2590723" cy="594360"/>
           </a:xfrm>
           <a:prstGeom prst="rect">
             <a:avLst/>
@@ -7706,8 +7706,8 @@
         </p:nvSpPr>
         <p:spPr>
           <a:xfrm>
-            <a:off x="3596563" y="3444240"/>
-            <a:ext cx="2407843" cy="464820"/>
+            <a:off x="3596563" y="3291840"/>
+            <a:ext cx="2407843" cy="502920"/>
           </a:xfrm>
           <a:prstGeom prst="rect">
             <a:avLst/>
@@ -7742,8 +7742,8 @@
         </p:nvSpPr>
         <p:spPr>
           <a:xfrm>
-            <a:off x="6095847" y="3398520"/>
-            <a:ext cx="2590723" cy="556260"/>
+            <a:off x="6095847" y="3246120"/>
+            <a:ext cx="2590723" cy="594360"/>
           </a:xfrm>
           <a:prstGeom prst="rect">
             <a:avLst/>
@@ -7787,8 +7787,8 @@
         </p:nvSpPr>
         <p:spPr>
           <a:xfrm>
-            <a:off x="6187287" y="3444240"/>
-            <a:ext cx="2407843" cy="464820"/>
+            <a:off x="6187287" y="3291840"/>
+            <a:ext cx="2407843" cy="502920"/>
           </a:xfrm>
           <a:prstGeom prst="rect">
             <a:avLst/>
@@ -7823,8 +7823,8 @@
         </p:nvSpPr>
         <p:spPr>
           <a:xfrm>
-            <a:off x="8686571" y="3398520"/>
-            <a:ext cx="2590723" cy="556260"/>
+            <a:off x="8686571" y="3246120"/>
+            <a:ext cx="2590723" cy="594360"/>
           </a:xfrm>
           <a:prstGeom prst="rect">
             <a:avLst/>
@@ -7868,8 +7868,8 @@
         </p:nvSpPr>
         <p:spPr>
           <a:xfrm>
-            <a:off x="8778011" y="3444240"/>
-            <a:ext cx="2407843" cy="464820"/>
+            <a:off x="8778011" y="3291840"/>
+            <a:ext cx="2407843" cy="502920"/>
           </a:xfrm>
           <a:prstGeom prst="rect">
             <a:avLst/>
@@ -7904,8 +7904,8 @@
         </p:nvSpPr>
         <p:spPr>
           <a:xfrm>
-            <a:off x="914400" y="3954780"/>
-            <a:ext cx="2590723" cy="556260"/>
+            <a:off x="914400" y="3840480"/>
+            <a:ext cx="2590723" cy="594360"/>
           </a:xfrm>
           <a:prstGeom prst="rect">
             <a:avLst/>
@@ -7949,8 +7949,8 @@
         </p:nvSpPr>
         <p:spPr>
           <a:xfrm>
-            <a:off x="1005840" y="4000500"/>
-            <a:ext cx="2407843" cy="464820"/>
+            <a:off x="1005840" y="3886200"/>
+            <a:ext cx="2407843" cy="502920"/>
           </a:xfrm>
           <a:prstGeom prst="rect">
             <a:avLst/>
@@ -7985,8 +7985,8 @@
         </p:nvSpPr>
         <p:spPr>
           <a:xfrm>
-            <a:off x="3505123" y="3954780"/>
-            <a:ext cx="2590723" cy="556260"/>
+            <a:off x="3505123" y="3840480"/>
+            <a:ext cx="2590723" cy="594360"/>
           </a:xfrm>
           <a:prstGeom prst="rect">
             <a:avLst/>
@@ -8030,8 +8030,8 @@
         </p:nvSpPr>
         <p:spPr>
           <a:xfrm>
-            <a:off x="3596563" y="4000500"/>
-            <a:ext cx="2407843" cy="464820"/>
+            <a:off x="3596563" y="3886200"/>
+            <a:ext cx="2407843" cy="502920"/>
           </a:xfrm>
           <a:prstGeom prst="rect">
             <a:avLst/>
@@ -8066,8 +8066,8 @@
         </p:nvSpPr>
         <p:spPr>
           <a:xfrm>
-            <a:off x="6095847" y="3954780"/>
-            <a:ext cx="2590723" cy="556260"/>
+            <a:off x="6095847" y="3840480"/>
+            <a:ext cx="2590723" cy="594360"/>
           </a:xfrm>
           <a:prstGeom prst="rect">
             <a:avLst/>
@@ -8111,8 +8111,8 @@
         </p:nvSpPr>
         <p:spPr>
           <a:xfrm>
-            <a:off x="6187287" y="4000500"/>
-            <a:ext cx="2407843" cy="464820"/>
+            <a:off x="6187287" y="3886200"/>
+            <a:ext cx="2407843" cy="502920"/>
           </a:xfrm>
           <a:prstGeom prst="rect">
             <a:avLst/>
@@ -8147,8 +8147,8 @@
         </p:nvSpPr>
         <p:spPr>
           <a:xfrm>
-            <a:off x="8686571" y="3954780"/>
-            <a:ext cx="2590723" cy="556260"/>
+            <a:off x="8686571" y="3840480"/>
+            <a:ext cx="2590723" cy="594360"/>
           </a:xfrm>
           <a:prstGeom prst="rect">
             <a:avLst/>
@@ -8192,8 +8192,8 @@
         </p:nvSpPr>
         <p:spPr>
           <a:xfrm>
-            <a:off x="8778011" y="4000500"/>
-            <a:ext cx="2407843" cy="464820"/>
+            <a:off x="8778011" y="3886200"/>
+            <a:ext cx="2407843" cy="502920"/>
           </a:xfrm>
           <a:prstGeom prst="rect">
             <a:avLst/>
@@ -8228,8 +8228,8 @@
         </p:nvSpPr>
         <p:spPr>
           <a:xfrm>
-            <a:off x="914400" y="4511040"/>
-            <a:ext cx="2590723" cy="556260"/>
+            <a:off x="914400" y="4434840"/>
+            <a:ext cx="2590723" cy="594360"/>
           </a:xfrm>
           <a:prstGeom prst="rect">
             <a:avLst/>
@@ -8273,8 +8273,8 @@
         </p:nvSpPr>
         <p:spPr>
           <a:xfrm>
-            <a:off x="1005840" y="4556760"/>
-            <a:ext cx="2407843" cy="464820"/>
+            <a:off x="1005840" y="4480560"/>
+            <a:ext cx="2407843" cy="502920"/>
           </a:xfrm>
           <a:prstGeom prst="rect">
             <a:avLst/>
@@ -8309,8 +8309,8 @@
         </p:nvSpPr>
         <p:spPr>
           <a:xfrm>
-            <a:off x="3505123" y="4511040"/>
-            <a:ext cx="2590723" cy="556260"/>
+            <a:off x="3505123" y="4434840"/>
+            <a:ext cx="2590723" cy="594360"/>
           </a:xfrm>
           <a:prstGeom prst="rect">
             <a:avLst/>
@@ -8354,8 +8354,8 @@
         </p:nvSpPr>
         <p:spPr>
           <a:xfrm>
-            <a:off x="3596563" y="4556760"/>
-            <a:ext cx="2407843" cy="464820"/>
+            <a:off x="3596563" y="4480560"/>
+            <a:ext cx="2407843" cy="502920"/>
           </a:xfrm>
           <a:prstGeom prst="rect">
             <a:avLst/>
@@ -8390,8 +8390,8 @@
         </p:nvSpPr>
         <p:spPr>
           <a:xfrm>
-            <a:off x="6095847" y="4511040"/>
-            <a:ext cx="2590723" cy="556260"/>
+            <a:off x="6095847" y="4434840"/>
+            <a:ext cx="2590723" cy="594360"/>
           </a:xfrm>
           <a:prstGeom prst="rect">
             <a:avLst/>
@@ -8435,8 +8435,8 @@
         </p:nvSpPr>
         <p:spPr>
           <a:xfrm>
-            <a:off x="6187287" y="4556760"/>
-            <a:ext cx="2407843" cy="464820"/>
+            <a:off x="6187287" y="4480560"/>
+            <a:ext cx="2407843" cy="502920"/>
           </a:xfrm>
           <a:prstGeom prst="rect">
             <a:avLst/>
@@ -8471,8 +8471,8 @@
         </p:nvSpPr>
         <p:spPr>
           <a:xfrm>
-            <a:off x="8686571" y="4511040"/>
-            <a:ext cx="2590723" cy="556260"/>
+            <a:off x="8686571" y="4434840"/>
+            <a:ext cx="2590723" cy="594360"/>
           </a:xfrm>
           <a:prstGeom prst="rect">
             <a:avLst/>
@@ -8516,8 +8516,8 @@
         </p:nvSpPr>
         <p:spPr>
           <a:xfrm>
-            <a:off x="8778011" y="4556760"/>
-            <a:ext cx="2407843" cy="464820"/>
+            <a:off x="8778011" y="4480560"/>
+            <a:ext cx="2407843" cy="502920"/>
           </a:xfrm>
           <a:prstGeom prst="rect">
             <a:avLst/>
@@ -8552,8 +8552,8 @@
         </p:nvSpPr>
         <p:spPr>
           <a:xfrm>
-            <a:off x="914400" y="5067300"/>
-            <a:ext cx="2590723" cy="556260"/>
+            <a:off x="914400" y="5029200"/>
+            <a:ext cx="2590723" cy="594360"/>
           </a:xfrm>
           <a:prstGeom prst="rect">
             <a:avLst/>
@@ -8597,8 +8597,8 @@
         </p:nvSpPr>
         <p:spPr>
           <a:xfrm>
-            <a:off x="1005840" y="5113020"/>
-            <a:ext cx="2407843" cy="464820"/>
+            <a:off x="1005840" y="5074920"/>
+            <a:ext cx="2407843" cy="502920"/>
           </a:xfrm>
           <a:prstGeom prst="rect">
             <a:avLst/>
@@ -8633,8 +8633,8 @@
         </p:nvSpPr>
         <p:spPr>
           <a:xfrm>
-            <a:off x="3505123" y="5067300"/>
-            <a:ext cx="2590723" cy="556260"/>
+            <a:off x="3505123" y="5029200"/>
+            <a:ext cx="2590723" cy="594360"/>
           </a:xfrm>
           <a:prstGeom prst="rect">
             <a:avLst/>
@@ -8678,8 +8678,8 @@
         </p:nvSpPr>
         <p:spPr>
           <a:xfrm>
-            <a:off x="3596563" y="5113020"/>
-            <a:ext cx="2407843" cy="464820"/>
+            <a:off x="3596563" y="5074920"/>
+            <a:ext cx="2407843" cy="502920"/>
           </a:xfrm>
           <a:prstGeom prst="rect">
             <a:avLst/>
@@ -8714,8 +8714,8 @@
         </p:nvSpPr>
         <p:spPr>
           <a:xfrm>
-            <a:off x="6095847" y="5067300"/>
-            <a:ext cx="2590723" cy="556260"/>
+            <a:off x="6095847" y="5029200"/>
+            <a:ext cx="2590723" cy="594360"/>
           </a:xfrm>
           <a:prstGeom prst="rect">
             <a:avLst/>
@@ -8759,8 +8759,8 @@
         </p:nvSpPr>
         <p:spPr>
           <a:xfrm>
-            <a:off x="6187287" y="5113020"/>
-            <a:ext cx="2407843" cy="464820"/>
+            <a:off x="6187287" y="5074920"/>
+            <a:ext cx="2407843" cy="502920"/>
           </a:xfrm>
           <a:prstGeom prst="rect">
             <a:avLst/>
@@ -8795,8 +8795,8 @@
         </p:nvSpPr>
         <p:spPr>
           <a:xfrm>
-            <a:off x="8686571" y="5067300"/>
-            <a:ext cx="2590723" cy="556260"/>
+            <a:off x="8686571" y="5029200"/>
+            <a:ext cx="2590723" cy="594360"/>
           </a:xfrm>
           <a:prstGeom prst="rect">
             <a:avLst/>
@@ -8840,8 +8840,8 @@
         </p:nvSpPr>
         <p:spPr>
           <a:xfrm>
-            <a:off x="8778011" y="5113020"/>
-            <a:ext cx="2407843" cy="464820"/>
+            <a:off x="8778011" y="5074920"/>
+            <a:ext cx="2407843" cy="502920"/>
           </a:xfrm>
           <a:prstGeom prst="rect">
             <a:avLst/>
@@ -9051,7 +9051,7 @@
         <p:spPr>
           <a:xfrm>
             <a:off x="914400" y="1005840"/>
-            <a:ext cx="10362895" cy="914400"/>
+            <a:ext cx="10362895" cy="822960"/>
           </a:xfrm>
           <a:prstGeom prst="rect">
             <a:avLst/>
@@ -9085,8 +9085,8 @@
         </p:nvSpPr>
         <p:spPr>
           <a:xfrm>
-            <a:off x="1371600" y="2286000"/>
-            <a:ext cx="50800" cy="3337560"/>
+            <a:off x="1371600" y="2057400"/>
+            <a:ext cx="50800" cy="3566160"/>
           </a:xfrm>
           <a:prstGeom prst="rect">
             <a:avLst/>
@@ -9171,8 +9171,8 @@
         </p:nvSpPr>
         <p:spPr>
           <a:xfrm>
-            <a:off x="1828800" y="2560320"/>
-            <a:ext cx="6400800" cy="1371600"/>
+            <a:off x="1828800" y="2331720"/>
+            <a:ext cx="5029200" cy="1371600"/>
           </a:xfrm>
           <a:prstGeom prst="rect">
             <a:avLst/>
@@ -9187,7 +9187,7 @@
           <a:p>
             <a:pPr algn="l"/>
             <a:r>
-              <a:rPr sz="4800" b="1">
+              <a:rPr sz="3900" b="1">
                 <a:solidFill>
                   <a:srgbClr val="C9A962"/>
                 </a:solidFill>
@@ -9206,8 +9206,8 @@
         </p:nvSpPr>
         <p:spPr>
           <a:xfrm>
-            <a:off x="1828800" y="3749040"/>
-            <a:ext cx="6400800" cy="548640"/>
+            <a:off x="1828800" y="3520440"/>
+            <a:ext cx="5029200" cy="548640"/>
           </a:xfrm>
           <a:prstGeom prst="rect">
             <a:avLst/>
@@ -9241,8 +9241,8 @@
         </p:nvSpPr>
         <p:spPr>
           <a:xfrm>
-            <a:off x="7772400" y="4434840"/>
-            <a:ext cx="3657600" cy="1097280"/>
+            <a:off x="7315200" y="4434840"/>
+            <a:ext cx="4114800" cy="1097280"/>
           </a:xfrm>
           <a:prstGeom prst="rect">
             <a:avLst/>

</xml_diff>